<commit_message>
docs(pitch-dshare): update slide 1 with RWA cover copy in PPTX, PDF, and HTML
</commit_message>
<xml_diff>
--- a/docs/publish/pitch-dshare/D-SHARE-Prime-Edition-15-Slides.pptx
+++ b/docs/publish/pitch-dshare/D-SHARE-Prime-Edition-15-Slides.pptx
@@ -1,31 +1,47 @@
 
 <file path=ppt/presentation.xml><?xml version="1.0" encoding="utf-8"?>
-<p:presentation xmlns:a="http://schemas.openxmlformats.org/drawingml/2006/main" xmlns:r="http://schemas.openxmlformats.org/officeDocument/2006/relationships" xmlns:p="http://schemas.openxmlformats.org/presentationml/2006/main" xmlns:m="http://schemas.openxmlformats.org/officeDocument/2006/math" xmlns:w="http://schemas.openxmlformats.org/wordprocessingml/2006/main">
+<p:presentation xmlns:a="http://schemas.openxmlformats.org/drawingml/2006/main" xmlns:r="http://schemas.openxmlformats.org/officeDocument/2006/relationships" xmlns:p="http://schemas.openxmlformats.org/presentationml/2006/main" xmlns:m="http://schemas.openxmlformats.org/officeDocument/2006/math" xmlns:w="http://schemas.openxmlformats.org/wordprocessingml/2006/main" xmlns:p14="http://schemas.microsoft.com/office/powerpoint/2010/main">
   <p:sldMasterIdLst>
-    <p:sldMasterId id="2147483648" r:id="rId1"/>
+    <p:sldMasterId id="2147483656" r:id="rId8"/>
   </p:sldMasterIdLst>
   <p:notesMasterIdLst>
-    <p:notesMasterId r:id="rId19"/>
+    <p:notesMasterId r:id="rId10"/>
   </p:notesMasterIdLst>
   <p:sldIdLst>
-    <p:sldId id="256" r:id="rId4"/>
-    <p:sldId id="257" r:id="rId5"/>
-    <p:sldId id="258" r:id="rId6"/>
-    <p:sldId id="259" r:id="rId7"/>
-    <p:sldId id="260" r:id="rId8"/>
-    <p:sldId id="261" r:id="rId9"/>
-    <p:sldId id="262" r:id="rId10"/>
-    <p:sldId id="263" r:id="rId11"/>
-    <p:sldId id="264" r:id="rId12"/>
-    <p:sldId id="265" r:id="rId13"/>
-    <p:sldId id="266" r:id="rId14"/>
-    <p:sldId id="267" r:id="rId15"/>
-    <p:sldId id="268" r:id="rId16"/>
-    <p:sldId id="269" r:id="rId17"/>
-    <p:sldId id="270" r:id="rId18"/>
+    <p:sldId id="256" r:id="rId12"/>
+    <p:sldId id="257" r:id="rId13"/>
+    <p:sldId id="258" r:id="rId15"/>
+    <p:sldId id="259" r:id="rId17"/>
+    <p:sldId id="260" r:id="rId19"/>
+    <p:sldId id="261" r:id="rId21"/>
+    <p:sldId id="262" r:id="rId23"/>
+    <p:sldId id="263" r:id="rId25"/>
+    <p:sldId id="264" r:id="rId27"/>
+    <p:sldId id="265" r:id="rId29"/>
+    <p:sldId id="266" r:id="rId31"/>
+    <p:sldId id="267" r:id="rId33"/>
+    <p:sldId id="268" r:id="rId35"/>
+    <p:sldId id="269" r:id="rId37"/>
+    <p:sldId id="270" r:id="rId39"/>
   </p:sldIdLst>
   <p:sldSz cx="12192000" cy="6858000"/>
   <p:notesSz cx="6858000" cy="9144000"/>
+  <p:extLst>
+    <p:ext uri="{EFAFB233-063F-42B5-8137-9DF3F51BA10A}">
+      <p15:sldGuideLst xmlns:p15="http://schemas.microsoft.com/office/powerpoint/2012/main">
+        <p15:guide id="0" pos="3839" userDrawn="1">
+          <p15:clr>
+            <a:srgbClr val="A4A3A4"/>
+          </p15:clr>
+        </p15:guide>
+        <p15:guide id="1" orient="horz" pos="2159" userDrawn="1">
+          <p15:clr>
+            <a:srgbClr val="A4A3A4"/>
+          </p15:clr>
+        </p15:guide>
+      </p15:sldGuideLst>
+    </p:ext>
+  </p:extLst>
 </p:presentation>
 </file>
 
@@ -5401,10 +5417,10 @@
 </file>
 
 <file path=ppt/slides/slide1.xml><?xml version="1.0" encoding="utf-8"?>
-<p:sld xmlns:a="http://schemas.openxmlformats.org/drawingml/2006/main" xmlns:r="http://schemas.openxmlformats.org/officeDocument/2006/relationships" xmlns:p="http://schemas.openxmlformats.org/presentationml/2006/main" xmlns:m="http://schemas.openxmlformats.org/officeDocument/2006/math" xmlns:w="http://schemas.openxmlformats.org/wordprocessingml/2006/main" xmlns:mc="http://schemas.openxmlformats.org/markup-compatibility/2006" showMasterPhAnim="0" showMasterSp="1" show="1">
+<p:sld xmlns:a="http://schemas.openxmlformats.org/drawingml/2006/main" xmlns:r="http://schemas.openxmlformats.org/officeDocument/2006/relationships" xmlns:p="http://schemas.openxmlformats.org/presentationml/2006/main" xmlns:m="http://schemas.openxmlformats.org/officeDocument/2006/math" xmlns:w="http://schemas.openxmlformats.org/wordprocessingml/2006/main" xmlns:mc="http://schemas.openxmlformats.org/markup-compatibility/2006" xmlns:p14="http://schemas.microsoft.com/office/powerpoint/2010/main" showMasterPhAnim="0">
   <p:cSld name="">
     <p:bg>
-      <p:bgPr shadeToTitle="0">
+      <p:bgPr>
         <a:solidFill>
           <a:srgbClr val="F7F4EC"/>
         </a:solidFill>
@@ -5426,7 +5442,7 @@
       </p:grpSpPr>
       <p:pic>
         <p:nvPicPr>
-          <p:cNvPr id="953846871" name=""/>
+          <p:cNvPr id="953846871" name="Picture 1"/>
           <p:cNvPicPr>
             <a:picLocks noChangeAspect="1"/>
           </p:cNvPicPr>
@@ -5459,7 +5475,7 @@
         </p:nvSpPr>
         <p:spPr bwMode="auto">
           <a:xfrm>
-            <a:off x="609600" y="438149"/>
+            <a:off x="609600" y="438150"/>
             <a:ext cx="6000750" cy="304800"/>
           </a:xfrm>
           <a:prstGeom prst="rect">
@@ -5977,7 +5993,7 @@
         <p:spPr bwMode="auto">
           <a:xfrm>
             <a:off x="647700" y="3724275"/>
-            <a:ext cx="6477000" cy="809625"/>
+            <a:ext cx="6477635" cy="810260"/>
           </a:xfrm>
           <a:prstGeom prst="rect">
             <a:avLst/>
@@ -5989,144 +6005,201 @@
           </a:ln>
         </p:spPr>
         <p:txBody>
-          <a:bodyPr wrap="square" lIns="0" tIns="0" rIns="0" bIns="0" anchor="t">
+          <a:bodyPr wrap="square" lIns="0" tIns="0" rIns="0" bIns="0" numCol="1" vert="horz" anchor="t">
             <a:noAutofit/>
           </a:bodyPr>
           <a:lstStyle>
-            <a:defPPr algn="l">
-              <a:defRPr sz="2100" b="0">
-                <a:solidFill>
-                  <a:srgbClr val="53676D"/>
-                </a:solidFill>
-                <a:latin typeface="Arial"/>
-                <a:ea typeface="Arial"/>
-                <a:cs typeface="Arial"/>
-              </a:defRPr>
-            </a:defPPr>
-            <a:lvl1pPr algn="l">
-              <a:buNone/>
-              <a:defRPr sz="2050" b="0">
-                <a:solidFill>
-                  <a:srgbClr val="53676D"/>
-                </a:solidFill>
-                <a:latin typeface="Arial"/>
-                <a:ea typeface="Arial"/>
-                <a:cs typeface="Arial"/>
+            <a:lvl1pPr marL="0" indent="0" algn="l">
+              <a:buFontTx/>
+              <a:buNone/>
+              <a:defRPr lang="en-GB" altLang="en-US" sz="2050" b="0">
+                <a:solidFill>
+                  <a:srgbClr val="53676D"/>
+                </a:solidFill>
+                <a:latin typeface="Arial" charset="0"/>
+                <a:ea typeface="Arial" charset="0"/>
+                <a:cs typeface="Arial" charset="0"/>
               </a:defRPr>
             </a:lvl1pPr>
-            <a:lvl2pPr algn="l">
-              <a:buNone/>
-              <a:defRPr sz="2050" b="0">
-                <a:solidFill>
-                  <a:srgbClr val="53676D"/>
-                </a:solidFill>
-                <a:latin typeface="Arial"/>
-                <a:ea typeface="Arial"/>
-                <a:cs typeface="Arial"/>
+            <a:lvl2pPr marL="0" indent="0" algn="l" lvl="1">
+              <a:buFontTx/>
+              <a:buNone/>
+              <a:defRPr lang="en-GB" altLang="en-US" sz="2050" b="0">
+                <a:solidFill>
+                  <a:srgbClr val="53676D"/>
+                </a:solidFill>
+                <a:latin typeface="Arial" charset="0"/>
+                <a:ea typeface="Arial" charset="0"/>
+                <a:cs typeface="Arial" charset="0"/>
               </a:defRPr>
             </a:lvl2pPr>
-            <a:lvl3pPr algn="l">
-              <a:buNone/>
-              <a:defRPr sz="2050" b="0">
-                <a:solidFill>
-                  <a:srgbClr val="53676D"/>
-                </a:solidFill>
-                <a:latin typeface="Arial"/>
-                <a:ea typeface="Arial"/>
-                <a:cs typeface="Arial"/>
+            <a:lvl3pPr marL="0" indent="0" algn="l" lvl="2">
+              <a:buFontTx/>
+              <a:buNone/>
+              <a:defRPr lang="en-GB" altLang="en-US" sz="2050" b="0">
+                <a:solidFill>
+                  <a:srgbClr val="53676D"/>
+                </a:solidFill>
+                <a:latin typeface="Arial" charset="0"/>
+                <a:ea typeface="Arial" charset="0"/>
+                <a:cs typeface="Arial" charset="0"/>
               </a:defRPr>
             </a:lvl3pPr>
-            <a:lvl4pPr algn="l">
-              <a:buNone/>
-              <a:defRPr sz="2050" b="0">
-                <a:solidFill>
-                  <a:srgbClr val="53676D"/>
-                </a:solidFill>
-                <a:latin typeface="Arial"/>
-                <a:ea typeface="Arial"/>
-                <a:cs typeface="Arial"/>
+            <a:lvl4pPr marL="0" indent="0" algn="l" lvl="3">
+              <a:buFontTx/>
+              <a:buNone/>
+              <a:defRPr lang="en-GB" altLang="en-US" sz="2050" b="0">
+                <a:solidFill>
+                  <a:srgbClr val="53676D"/>
+                </a:solidFill>
+                <a:latin typeface="Arial" charset="0"/>
+                <a:ea typeface="Arial" charset="0"/>
+                <a:cs typeface="Arial" charset="0"/>
               </a:defRPr>
             </a:lvl4pPr>
-            <a:lvl5pPr algn="l">
-              <a:buNone/>
-              <a:defRPr sz="2050" b="0">
-                <a:solidFill>
-                  <a:srgbClr val="53676D"/>
-                </a:solidFill>
-                <a:latin typeface="Arial"/>
-                <a:ea typeface="Arial"/>
-                <a:cs typeface="Arial"/>
+            <a:lvl5pPr marL="0" indent="0" algn="l" lvl="4">
+              <a:buFontTx/>
+              <a:buNone/>
+              <a:defRPr lang="en-GB" altLang="en-US" sz="2050" b="0">
+                <a:solidFill>
+                  <a:srgbClr val="53676D"/>
+                </a:solidFill>
+                <a:latin typeface="Arial" charset="0"/>
+                <a:ea typeface="Arial" charset="0"/>
+                <a:cs typeface="Arial" charset="0"/>
               </a:defRPr>
             </a:lvl5pPr>
-            <a:lvl6pPr algn="l">
-              <a:buNone/>
-              <a:defRPr sz="2050" b="0">
-                <a:solidFill>
-                  <a:srgbClr val="53676D"/>
-                </a:solidFill>
-                <a:latin typeface="Arial"/>
-                <a:ea typeface="Arial"/>
-                <a:cs typeface="Arial"/>
+            <a:lvl6pPr marL="0" indent="0" algn="l" lvl="5">
+              <a:buFontTx/>
+              <a:buNone/>
+              <a:defRPr lang="en-GB" altLang="en-US" sz="2050" b="0">
+                <a:solidFill>
+                  <a:srgbClr val="53676D"/>
+                </a:solidFill>
+                <a:latin typeface="Arial" charset="0"/>
+                <a:ea typeface="Arial" charset="0"/>
+                <a:cs typeface="Arial" charset="0"/>
               </a:defRPr>
             </a:lvl6pPr>
-            <a:lvl7pPr algn="l">
-              <a:buNone/>
-              <a:defRPr sz="2050" b="0">
-                <a:solidFill>
-                  <a:srgbClr val="53676D"/>
-                </a:solidFill>
-                <a:latin typeface="Arial"/>
-                <a:ea typeface="Arial"/>
-                <a:cs typeface="Arial"/>
+            <a:lvl7pPr marL="0" indent="0" algn="l" lvl="6">
+              <a:buFontTx/>
+              <a:buNone/>
+              <a:defRPr lang="en-GB" altLang="en-US" sz="2050" b="0">
+                <a:solidFill>
+                  <a:srgbClr val="53676D"/>
+                </a:solidFill>
+                <a:latin typeface="Arial" charset="0"/>
+                <a:ea typeface="Arial" charset="0"/>
+                <a:cs typeface="Arial" charset="0"/>
               </a:defRPr>
             </a:lvl7pPr>
-            <a:lvl8pPr algn="l">
-              <a:buNone/>
-              <a:defRPr sz="2050" b="0">
-                <a:solidFill>
-                  <a:srgbClr val="53676D"/>
-                </a:solidFill>
-                <a:latin typeface="Arial"/>
-                <a:ea typeface="Arial"/>
-                <a:cs typeface="Arial"/>
+            <a:lvl8pPr marL="0" indent="0" algn="l" lvl="7">
+              <a:buFontTx/>
+              <a:buNone/>
+              <a:defRPr lang="en-GB" altLang="en-US" sz="2050" b="0">
+                <a:solidFill>
+                  <a:srgbClr val="53676D"/>
+                </a:solidFill>
+                <a:latin typeface="Arial" charset="0"/>
+                <a:ea typeface="Arial" charset="0"/>
+                <a:cs typeface="Arial" charset="0"/>
               </a:defRPr>
             </a:lvl8pPr>
-            <a:lvl9pPr algn="l">
-              <a:buNone/>
-              <a:defRPr sz="2050" b="0">
-                <a:solidFill>
-                  <a:srgbClr val="53676D"/>
-                </a:solidFill>
-                <a:latin typeface="Arial"/>
-                <a:ea typeface="Arial"/>
-                <a:cs typeface="Arial"/>
+            <a:lvl9pPr marL="0" indent="0" algn="l" lvl="8">
+              <a:buFontTx/>
+              <a:buNone/>
+              <a:defRPr lang="en-GB" altLang="en-US" sz="2050" b="0">
+                <a:solidFill>
+                  <a:srgbClr val="53676D"/>
+                </a:solidFill>
+                <a:latin typeface="Arial" charset="0"/>
+                <a:ea typeface="Arial" charset="0"/>
+                <a:cs typeface="Arial" charset="0"/>
               </a:defRPr>
             </a:lvl9pPr>
           </a:lstStyle>
           <a:p>
-            <a:pPr algn="l">
+            <a:pPr marL="0" indent="0" algn="l">
+              <a:buFontTx/>
               <a:buNone/>
               <a:defRPr sz="2100" b="0">
                 <a:solidFill>
                   <a:srgbClr val="53676D"/>
                 </a:solidFill>
-                <a:latin typeface="Arial"/>
-                <a:ea typeface="Arial"/>
-                <a:cs typeface="Arial"/>
+                <a:latin typeface="Arial" charset="0"/>
+                <a:ea typeface="Arial" charset="0"/>
+                <a:cs typeface="Arial" charset="0"/>
               </a:defRPr>
             </a:pPr>
             <a:r>
+              <a:rPr sz="2100" b="1">
+                <a:solidFill>
+                  <a:srgbClr val="53676D"/>
+                </a:solidFill>
+                <a:effectLst>
+                  <a:outerShdw sx="100000" sy="100000" blurRad="38100" dist="38100" dir="2700000" rotWithShape="0" algn="ctr">
+                    <a:srgbClr val="000000">
+                      <a:alpha val="43000"/>
+                    </a:srgbClr>
+                  </a:outerShdw>
+                </a:effectLst>
+                <a:latin typeface="Arial" charset="0"/>
+                <a:ea typeface="Arial" charset="0"/>
+                <a:cs typeface="Arial" charset="0"/>
+              </a:rPr>
+              <a:t>RWA - Real World Assets</a:t>
+            </a:r>
+            <a:r>
               <a:rPr sz="2100" b="0">
                 <a:solidFill>
                   <a:srgbClr val="53676D"/>
                 </a:solidFill>
-                <a:latin typeface="Arial"/>
-                <a:ea typeface="Arial"/>
-                <a:cs typeface="Arial"/>
+                <a:latin typeface="Arial" charset="0"/>
+                <a:ea typeface="Arial" charset="0"/>
+                <a:cs typeface="Arial" charset="0"/>
+              </a:rPr>
+              <a:t/>
+            </a:r>
+            <a:br>
+              <a:rPr sz="2100" b="0">
+                <a:solidFill>
+                  <a:srgbClr val="53676D"/>
+                </a:solidFill>
+                <a:latin typeface="Arial" charset="0"/>
+                <a:ea typeface="Arial" charset="0"/>
+                <a:cs typeface="Arial" charset="0"/>
+              </a:rPr>
+            </a:br>
+            <a:r>
+              <a:rPr sz="2100" b="0">
+                <a:solidFill>
+                  <a:srgbClr val="53676D"/>
+                </a:solidFill>
+                <a:latin typeface="Arial" charset="0"/>
+                <a:ea typeface="Arial" charset="0"/>
+                <a:cs typeface="Arial" charset="0"/>
+              </a:rPr>
+              <a:t>        </a:t>
+            </a:r>
+            <a:r>
+              <a:rPr sz="2100" b="0">
+                <a:solidFill>
+                  <a:srgbClr val="53676D"/>
+                </a:solidFill>
+                <a:latin typeface="Arial" charset="0"/>
+                <a:ea typeface="Arial" charset="0"/>
+                <a:cs typeface="Arial" charset="0"/>
               </a:rPr>
               <a:t>Tokenized depository receipts.</a:t>
             </a:r>
-            <a:endParaRPr/>
+            <a:endParaRPr lang="ko-KR" altLang="en-US" sz="2100" b="0">
+              <a:solidFill>
+                <a:srgbClr val="53676D"/>
+              </a:solidFill>
+              <a:latin typeface="Arial" charset="0"/>
+              <a:ea typeface="Arial" charset="0"/>
+              <a:cs typeface="Arial" charset="0"/>
+            </a:endParaRPr>
           </a:p>
         </p:txBody>
       </p:sp>
@@ -6796,8 +6869,8 @@
         </p:nvSpPr>
         <p:spPr bwMode="auto">
           <a:xfrm>
-            <a:off x="8436497" y="909637"/>
-            <a:ext cx="6953250" cy="638175"/>
+            <a:off x="8436610" y="909320"/>
+            <a:ext cx="6953885" cy="638810"/>
           </a:xfrm>
           <a:prstGeom prst="rect">
             <a:avLst/>
@@ -6809,130 +6882,130 @@
           </a:ln>
         </p:spPr>
         <p:txBody>
-          <a:bodyPr wrap="square" lIns="0" tIns="0" rIns="0" bIns="0" anchor="t">
+          <a:bodyPr wrap="square" lIns="0" tIns="0" rIns="0" bIns="0" numCol="1" vert="horz" anchor="t">
             <a:noAutofit/>
           </a:bodyPr>
           <a:lstStyle>
-            <a:defPPr algn="l">
-              <a:defRPr sz="1750" b="0">
-                <a:solidFill>
-                  <a:srgbClr val="53676D"/>
-                </a:solidFill>
-                <a:latin typeface="Arial"/>
-                <a:ea typeface="Arial"/>
-                <a:cs typeface="Arial"/>
-              </a:defRPr>
-            </a:defPPr>
-            <a:lvl1pPr algn="l">
-              <a:buNone/>
-              <a:defRPr sz="1750" b="0">
-                <a:solidFill>
-                  <a:srgbClr val="53676D"/>
-                </a:solidFill>
-                <a:latin typeface="Arial"/>
-                <a:ea typeface="Arial"/>
-                <a:cs typeface="Arial"/>
+            <a:lvl1pPr marL="0" indent="0" algn="l">
+              <a:buFontTx/>
+              <a:buNone/>
+              <a:defRPr lang="en-GB" altLang="en-US" sz="1750" b="0">
+                <a:solidFill>
+                  <a:srgbClr val="53676D"/>
+                </a:solidFill>
+                <a:latin typeface="Arial" charset="0"/>
+                <a:ea typeface="Arial" charset="0"/>
+                <a:cs typeface="Arial" charset="0"/>
               </a:defRPr>
             </a:lvl1pPr>
-            <a:lvl2pPr algn="l">
-              <a:buNone/>
-              <a:defRPr sz="1750" b="0">
-                <a:solidFill>
-                  <a:srgbClr val="53676D"/>
-                </a:solidFill>
-                <a:latin typeface="Arial"/>
-                <a:ea typeface="Arial"/>
-                <a:cs typeface="Arial"/>
+            <a:lvl2pPr marL="0" indent="0" algn="l" lvl="1">
+              <a:buFontTx/>
+              <a:buNone/>
+              <a:defRPr lang="en-GB" altLang="en-US" sz="1750" b="0">
+                <a:solidFill>
+                  <a:srgbClr val="53676D"/>
+                </a:solidFill>
+                <a:latin typeface="Arial" charset="0"/>
+                <a:ea typeface="Arial" charset="0"/>
+                <a:cs typeface="Arial" charset="0"/>
               </a:defRPr>
             </a:lvl2pPr>
-            <a:lvl3pPr algn="l">
-              <a:buNone/>
-              <a:defRPr sz="1750" b="0">
-                <a:solidFill>
-                  <a:srgbClr val="53676D"/>
-                </a:solidFill>
-                <a:latin typeface="Arial"/>
-                <a:ea typeface="Arial"/>
-                <a:cs typeface="Arial"/>
+            <a:lvl3pPr marL="0" indent="0" algn="l" lvl="2">
+              <a:buFontTx/>
+              <a:buNone/>
+              <a:defRPr lang="en-GB" altLang="en-US" sz="1750" b="0">
+                <a:solidFill>
+                  <a:srgbClr val="53676D"/>
+                </a:solidFill>
+                <a:latin typeface="Arial" charset="0"/>
+                <a:ea typeface="Arial" charset="0"/>
+                <a:cs typeface="Arial" charset="0"/>
               </a:defRPr>
             </a:lvl3pPr>
-            <a:lvl4pPr algn="l">
-              <a:buNone/>
-              <a:defRPr sz="1750" b="0">
-                <a:solidFill>
-                  <a:srgbClr val="53676D"/>
-                </a:solidFill>
-                <a:latin typeface="Arial"/>
-                <a:ea typeface="Arial"/>
-                <a:cs typeface="Arial"/>
+            <a:lvl4pPr marL="0" indent="0" algn="l" lvl="3">
+              <a:buFontTx/>
+              <a:buNone/>
+              <a:defRPr lang="en-GB" altLang="en-US" sz="1750" b="0">
+                <a:solidFill>
+                  <a:srgbClr val="53676D"/>
+                </a:solidFill>
+                <a:latin typeface="Arial" charset="0"/>
+                <a:ea typeface="Arial" charset="0"/>
+                <a:cs typeface="Arial" charset="0"/>
               </a:defRPr>
             </a:lvl4pPr>
-            <a:lvl5pPr algn="l">
-              <a:buNone/>
-              <a:defRPr sz="1750" b="0">
-                <a:solidFill>
-                  <a:srgbClr val="53676D"/>
-                </a:solidFill>
-                <a:latin typeface="Arial"/>
-                <a:ea typeface="Arial"/>
-                <a:cs typeface="Arial"/>
+            <a:lvl5pPr marL="0" indent="0" algn="l" lvl="4">
+              <a:buFontTx/>
+              <a:buNone/>
+              <a:defRPr lang="en-GB" altLang="en-US" sz="1750" b="0">
+                <a:solidFill>
+                  <a:srgbClr val="53676D"/>
+                </a:solidFill>
+                <a:latin typeface="Arial" charset="0"/>
+                <a:ea typeface="Arial" charset="0"/>
+                <a:cs typeface="Arial" charset="0"/>
               </a:defRPr>
             </a:lvl5pPr>
-            <a:lvl6pPr algn="l">
-              <a:buNone/>
-              <a:defRPr sz="1750" b="0">
-                <a:solidFill>
-                  <a:srgbClr val="53676D"/>
-                </a:solidFill>
-                <a:latin typeface="Arial"/>
-                <a:ea typeface="Arial"/>
-                <a:cs typeface="Arial"/>
+            <a:lvl6pPr marL="0" indent="0" algn="l" lvl="5">
+              <a:buFontTx/>
+              <a:buNone/>
+              <a:defRPr lang="en-GB" altLang="en-US" sz="1750" b="0">
+                <a:solidFill>
+                  <a:srgbClr val="53676D"/>
+                </a:solidFill>
+                <a:latin typeface="Arial" charset="0"/>
+                <a:ea typeface="Arial" charset="0"/>
+                <a:cs typeface="Arial" charset="0"/>
               </a:defRPr>
             </a:lvl6pPr>
-            <a:lvl7pPr algn="l">
-              <a:buNone/>
-              <a:defRPr sz="1750" b="0">
-                <a:solidFill>
-                  <a:srgbClr val="53676D"/>
-                </a:solidFill>
-                <a:latin typeface="Arial"/>
-                <a:ea typeface="Arial"/>
-                <a:cs typeface="Arial"/>
+            <a:lvl7pPr marL="0" indent="0" algn="l" lvl="6">
+              <a:buFontTx/>
+              <a:buNone/>
+              <a:defRPr lang="en-GB" altLang="en-US" sz="1750" b="0">
+                <a:solidFill>
+                  <a:srgbClr val="53676D"/>
+                </a:solidFill>
+                <a:latin typeface="Arial" charset="0"/>
+                <a:ea typeface="Arial" charset="0"/>
+                <a:cs typeface="Arial" charset="0"/>
               </a:defRPr>
             </a:lvl7pPr>
-            <a:lvl8pPr algn="l">
-              <a:buNone/>
-              <a:defRPr sz="1750" b="0">
-                <a:solidFill>
-                  <a:srgbClr val="53676D"/>
-                </a:solidFill>
-                <a:latin typeface="Arial"/>
-                <a:ea typeface="Arial"/>
-                <a:cs typeface="Arial"/>
+            <a:lvl8pPr marL="0" indent="0" algn="l" lvl="7">
+              <a:buFontTx/>
+              <a:buNone/>
+              <a:defRPr lang="en-GB" altLang="en-US" sz="1750" b="0">
+                <a:solidFill>
+                  <a:srgbClr val="53676D"/>
+                </a:solidFill>
+                <a:latin typeface="Arial" charset="0"/>
+                <a:ea typeface="Arial" charset="0"/>
+                <a:cs typeface="Arial" charset="0"/>
               </a:defRPr>
             </a:lvl8pPr>
-            <a:lvl9pPr algn="l">
-              <a:buNone/>
-              <a:defRPr sz="1750" b="0">
-                <a:solidFill>
-                  <a:srgbClr val="53676D"/>
-                </a:solidFill>
-                <a:latin typeface="Arial"/>
-                <a:ea typeface="Arial"/>
-                <a:cs typeface="Arial"/>
+            <a:lvl9pPr marL="0" indent="0" algn="l" lvl="8">
+              <a:buFontTx/>
+              <a:buNone/>
+              <a:defRPr lang="en-GB" altLang="en-US" sz="1750" b="0">
+                <a:solidFill>
+                  <a:srgbClr val="53676D"/>
+                </a:solidFill>
+                <a:latin typeface="Arial" charset="0"/>
+                <a:ea typeface="Arial" charset="0"/>
+                <a:cs typeface="Arial" charset="0"/>
               </a:defRPr>
             </a:lvl9pPr>
           </a:lstStyle>
           <a:p>
-            <a:pPr algn="l">
+            <a:pPr marL="0" indent="0" algn="l">
+              <a:buFontTx/>
               <a:buNone/>
               <a:defRPr sz="1750" b="0">
                 <a:solidFill>
                   <a:srgbClr val="53676D"/>
                 </a:solidFill>
-                <a:latin typeface="Arial"/>
-                <a:ea typeface="Arial"/>
-                <a:cs typeface="Arial"/>
+                <a:latin typeface="Arial" charset="0"/>
+                <a:ea typeface="Arial" charset="0"/>
+                <a:cs typeface="Arial" charset="0"/>
               </a:defRPr>
             </a:pPr>
             <a:r>
@@ -6940,9 +7013,9 @@
                 <a:solidFill>
                   <a:srgbClr val="53676D"/>
                 </a:solidFill>
-                <a:latin typeface="Arial"/>
-                <a:ea typeface="Arial"/>
-                <a:cs typeface="Arial"/>
+                <a:latin typeface="Arial" charset="0"/>
+                <a:ea typeface="Arial" charset="0"/>
+                <a:cs typeface="Arial" charset="0"/>
               </a:rPr>
               <a:t>D</a:t>
             </a:r>
@@ -6951,45 +7024,47 @@
                 <a:solidFill>
                   <a:srgbClr val="53676D"/>
                 </a:solidFill>
-                <a:latin typeface="Arial"/>
-                <a:ea typeface="Arial"/>
-                <a:cs typeface="Arial"/>
+                <a:latin typeface="Arial" charset="0"/>
+                <a:ea typeface="Arial" charset="0"/>
+                <a:cs typeface="Arial" charset="0"/>
               </a:rPr>
               <a:t>epository Framework</a:t>
             </a:r>
-            <a:endParaRPr sz="2600" b="0">
+            <a:endParaRPr lang="ko-KR" altLang="en-US" sz="2600" b="0">
               <a:solidFill>
                 <a:srgbClr val="53676D"/>
               </a:solidFill>
-              <a:latin typeface="Arial"/>
-              <a:ea typeface="Arial"/>
-              <a:cs typeface="Arial"/>
+              <a:latin typeface="Arial" charset="0"/>
+              <a:ea typeface="Arial" charset="0"/>
+              <a:cs typeface="Arial" charset="0"/>
             </a:endParaRPr>
           </a:p>
           <a:p>
-            <a:pPr algn="l">
+            <a:pPr marL="0" indent="0" algn="l">
+              <a:buFontTx/>
               <a:buNone/>
               <a:defRPr sz="1750" b="0">
                 <a:solidFill>
                   <a:srgbClr val="53676D"/>
                 </a:solidFill>
-                <a:latin typeface="Arial"/>
-                <a:ea typeface="Arial"/>
-                <a:cs typeface="Arial"/>
+                <a:latin typeface="Arial" charset="0"/>
+                <a:ea typeface="Arial" charset="0"/>
+                <a:cs typeface="Arial" charset="0"/>
               </a:defRPr>
             </a:pPr>
-            <a:endParaRPr sz="2600"/>
+            <a:endParaRPr lang="ko-KR" altLang="en-US" sz="2600"/>
           </a:p>
           <a:p>
-            <a:pPr algn="l">
+            <a:pPr marL="0" indent="0" algn="l">
+              <a:buFontTx/>
               <a:buNone/>
               <a:defRPr sz="1750" b="0">
                 <a:solidFill>
                   <a:srgbClr val="53676D"/>
                 </a:solidFill>
-                <a:latin typeface="Arial"/>
-                <a:ea typeface="Arial"/>
-                <a:cs typeface="Arial"/>
+                <a:latin typeface="Arial" charset="0"/>
+                <a:ea typeface="Arial" charset="0"/>
+                <a:cs typeface="Arial" charset="0"/>
               </a:defRPr>
             </a:pPr>
             <a:r>
@@ -6997,63 +7072,65 @@
                 <a:solidFill>
                   <a:srgbClr val="53676D"/>
                 </a:solidFill>
-                <a:latin typeface="Arial"/>
-                <a:ea typeface="Arial"/>
-                <a:cs typeface="Arial"/>
+                <a:latin typeface="Arial" charset="0"/>
+                <a:ea typeface="Arial" charset="0"/>
+                <a:cs typeface="Arial" charset="0"/>
               </a:rPr>
               <a:t>S</a:t>
             </a:r>
             <a:r>
-              <a:rPr sz="2600" b="0">
-                <a:solidFill>
-                  <a:srgbClr val="53676D"/>
-                </a:solidFill>
-                <a:latin typeface="Arial"/>
-                <a:ea typeface="Arial"/>
-                <a:cs typeface="Arial"/>
+              <a:rPr sz="2800" b="0">
+                <a:solidFill>
+                  <a:srgbClr val="53676D"/>
+                </a:solidFill>
+                <a:latin typeface="Arial" charset="0"/>
+                <a:ea typeface="Arial" charset="0"/>
+                <a:cs typeface="Arial" charset="0"/>
               </a:rPr>
               <a:t>ecurities </a:t>
             </a:r>
-            <a:endParaRPr sz="2600" b="0">
+            <a:endParaRPr lang="ko-KR" altLang="en-US" sz="2800" b="0">
               <a:solidFill>
                 <a:srgbClr val="53676D"/>
               </a:solidFill>
-              <a:latin typeface="Arial"/>
-              <a:ea typeface="Arial"/>
-              <a:cs typeface="Arial"/>
+              <a:latin typeface="Arial" charset="0"/>
+              <a:ea typeface="Arial" charset="0"/>
+              <a:cs typeface="Arial" charset="0"/>
             </a:endParaRPr>
           </a:p>
           <a:p>
-            <a:pPr algn="l">
+            <a:pPr marL="0" indent="0" algn="l">
+              <a:buFontTx/>
               <a:buNone/>
               <a:defRPr sz="1750" b="0">
                 <a:solidFill>
                   <a:srgbClr val="53676D"/>
                 </a:solidFill>
-                <a:latin typeface="Arial"/>
-                <a:ea typeface="Arial"/>
-                <a:cs typeface="Arial"/>
+                <a:latin typeface="Arial" charset="0"/>
+                <a:ea typeface="Arial" charset="0"/>
+                <a:cs typeface="Arial" charset="0"/>
               </a:defRPr>
             </a:pPr>
-            <a:endParaRPr sz="2600" b="0">
+            <a:endParaRPr lang="ko-KR" altLang="en-US" sz="2800" b="0">
               <a:solidFill>
                 <a:srgbClr val="53676D"/>
               </a:solidFill>
-              <a:latin typeface="Arial"/>
-              <a:ea typeface="Arial"/>
-              <a:cs typeface="Arial"/>
+              <a:latin typeface="Arial" charset="0"/>
+              <a:ea typeface="Arial" charset="0"/>
+              <a:cs typeface="Arial" charset="0"/>
             </a:endParaRPr>
           </a:p>
           <a:p>
-            <a:pPr algn="l">
+            <a:pPr marL="0" indent="0" algn="l">
+              <a:buFontTx/>
               <a:buNone/>
               <a:defRPr sz="1750" b="0">
                 <a:solidFill>
                   <a:srgbClr val="53676D"/>
                 </a:solidFill>
-                <a:latin typeface="Arial"/>
-                <a:ea typeface="Arial"/>
-                <a:cs typeface="Arial"/>
+                <a:latin typeface="Arial" charset="0"/>
+                <a:ea typeface="Arial" charset="0"/>
+                <a:cs typeface="Arial" charset="0"/>
               </a:defRPr>
             </a:pPr>
             <a:r>
@@ -7061,63 +7138,65 @@
                 <a:solidFill>
                   <a:srgbClr val="53676D"/>
                 </a:solidFill>
-                <a:latin typeface="Arial"/>
-                <a:ea typeface="Arial"/>
-                <a:cs typeface="Arial"/>
+                <a:latin typeface="Arial" charset="0"/>
+                <a:ea typeface="Arial" charset="0"/>
+                <a:cs typeface="Arial" charset="0"/>
               </a:rPr>
               <a:t>H</a:t>
             </a:r>
             <a:r>
-              <a:rPr sz="2600" b="0">
-                <a:solidFill>
-                  <a:srgbClr val="53676D"/>
-                </a:solidFill>
-                <a:latin typeface="Arial"/>
-                <a:ea typeface="Arial"/>
-                <a:cs typeface="Arial"/>
+              <a:rPr sz="2800" b="0">
+                <a:solidFill>
+                  <a:srgbClr val="53676D"/>
+                </a:solidFill>
+                <a:latin typeface="Arial" charset="0"/>
+                <a:ea typeface="Arial" charset="0"/>
+                <a:cs typeface="Arial" charset="0"/>
               </a:rPr>
               <a:t>oming </a:t>
             </a:r>
-            <a:endParaRPr sz="2600" b="0">
+            <a:endParaRPr lang="ko-KR" altLang="en-US" sz="2800" b="0">
               <a:solidFill>
                 <a:srgbClr val="53676D"/>
               </a:solidFill>
-              <a:latin typeface="Arial"/>
-              <a:ea typeface="Arial"/>
-              <a:cs typeface="Arial"/>
+              <a:latin typeface="Arial" charset="0"/>
+              <a:ea typeface="Arial" charset="0"/>
+              <a:cs typeface="Arial" charset="0"/>
             </a:endParaRPr>
           </a:p>
           <a:p>
-            <a:pPr algn="l">
+            <a:pPr marL="0" indent="0" algn="l">
+              <a:buFontTx/>
               <a:buNone/>
               <a:defRPr sz="1750" b="0">
                 <a:solidFill>
                   <a:srgbClr val="53676D"/>
                 </a:solidFill>
-                <a:latin typeface="Arial"/>
-                <a:ea typeface="Arial"/>
-                <a:cs typeface="Arial"/>
+                <a:latin typeface="Arial" charset="0"/>
+                <a:ea typeface="Arial" charset="0"/>
+                <a:cs typeface="Arial" charset="0"/>
               </a:defRPr>
             </a:pPr>
-            <a:endParaRPr sz="2600" b="0">
+            <a:endParaRPr lang="ko-KR" altLang="en-US" sz="2800" b="0">
               <a:solidFill>
                 <a:srgbClr val="53676D"/>
               </a:solidFill>
-              <a:latin typeface="Arial"/>
-              <a:ea typeface="Arial"/>
-              <a:cs typeface="Arial"/>
+              <a:latin typeface="Arial" charset="0"/>
+              <a:ea typeface="Arial" charset="0"/>
+              <a:cs typeface="Arial" charset="0"/>
             </a:endParaRPr>
           </a:p>
           <a:p>
-            <a:pPr algn="l">
+            <a:pPr marL="0" indent="0" algn="l">
+              <a:buFontTx/>
               <a:buNone/>
               <a:defRPr sz="1750" b="0">
                 <a:solidFill>
                   <a:srgbClr val="53676D"/>
                 </a:solidFill>
-                <a:latin typeface="Arial"/>
-                <a:ea typeface="Arial"/>
-                <a:cs typeface="Arial"/>
+                <a:latin typeface="Arial" charset="0"/>
+                <a:ea typeface="Arial" charset="0"/>
+                <a:cs typeface="Arial" charset="0"/>
               </a:defRPr>
             </a:pPr>
             <a:r>
@@ -7125,67 +7204,58 @@
                 <a:solidFill>
                   <a:srgbClr val="53676D"/>
                 </a:solidFill>
-                <a:latin typeface="Arial"/>
-                <a:ea typeface="Arial"/>
-                <a:cs typeface="Arial"/>
+                <a:latin typeface="Arial" charset="0"/>
+                <a:ea typeface="Arial" charset="0"/>
+                <a:cs typeface="Arial" charset="0"/>
               </a:rPr>
               <a:t>A</a:t>
             </a:r>
             <a:r>
-              <a:rPr sz="2600" b="0">
-                <a:solidFill>
-                  <a:srgbClr val="53676D"/>
-                </a:solidFill>
-                <a:latin typeface="Arial"/>
-                <a:ea typeface="Arial"/>
-                <a:cs typeface="Arial"/>
+              <a:rPr sz="2800" b="0">
+                <a:solidFill>
+                  <a:srgbClr val="53676D"/>
+                </a:solidFill>
+                <a:latin typeface="Arial" charset="0"/>
+                <a:ea typeface="Arial" charset="0"/>
+                <a:cs typeface="Arial" charset="0"/>
               </a:rPr>
-              <a:t>ccess </a:t>
+              <a:t>ccess to </a:t>
             </a:r>
-            <a:r>
-              <a:rPr sz="2600" b="0">
-                <a:solidFill>
-                  <a:srgbClr val="53676D"/>
-                </a:solidFill>
-                <a:latin typeface="Arial"/>
-                <a:ea typeface="Arial"/>
-                <a:cs typeface="Arial"/>
-              </a:rPr>
-              <a:t>to </a:t>
-            </a:r>
-            <a:endParaRPr sz="2600" b="0">
+            <a:endParaRPr lang="ko-KR" altLang="en-US" sz="2800" b="0">
               <a:solidFill>
                 <a:srgbClr val="53676D"/>
               </a:solidFill>
-              <a:latin typeface="Arial"/>
-              <a:ea typeface="Arial"/>
-              <a:cs typeface="Arial"/>
+              <a:latin typeface="Arial" charset="0"/>
+              <a:ea typeface="Arial" charset="0"/>
+              <a:cs typeface="Arial" charset="0"/>
             </a:endParaRPr>
           </a:p>
           <a:p>
-            <a:pPr algn="l">
+            <a:pPr marL="0" indent="0" algn="l">
+              <a:buFontTx/>
               <a:buNone/>
               <a:defRPr sz="1750" b="0">
                 <a:solidFill>
                   <a:srgbClr val="53676D"/>
                 </a:solidFill>
-                <a:latin typeface="Arial"/>
-                <a:ea typeface="Arial"/>
-                <a:cs typeface="Arial"/>
+                <a:latin typeface="Arial" charset="0"/>
+                <a:ea typeface="Arial" charset="0"/>
+                <a:cs typeface="Arial" charset="0"/>
               </a:defRPr>
             </a:pPr>
-            <a:endParaRPr sz="2600"/>
+            <a:endParaRPr lang="ko-KR" altLang="en-US" sz="2800"/>
           </a:p>
           <a:p>
-            <a:pPr algn="l">
+            <a:pPr marL="0" indent="0" algn="l">
+              <a:buFontTx/>
               <a:buNone/>
               <a:defRPr sz="1750" b="0">
                 <a:solidFill>
                   <a:srgbClr val="53676D"/>
                 </a:solidFill>
-                <a:latin typeface="Arial"/>
-                <a:ea typeface="Arial"/>
-                <a:cs typeface="Arial"/>
+                <a:latin typeface="Arial" charset="0"/>
+                <a:ea typeface="Arial" charset="0"/>
+                <a:cs typeface="Arial" charset="0"/>
               </a:defRPr>
             </a:pPr>
             <a:r>
@@ -7193,63 +7263,65 @@
                 <a:solidFill>
                   <a:srgbClr val="53676D"/>
                 </a:solidFill>
-                <a:latin typeface="Arial"/>
-                <a:ea typeface="Arial"/>
-                <a:cs typeface="Arial"/>
+                <a:latin typeface="Arial" charset="0"/>
+                <a:ea typeface="Arial" charset="0"/>
+                <a:cs typeface="Arial" charset="0"/>
               </a:rPr>
               <a:t>R</a:t>
             </a:r>
             <a:r>
-              <a:rPr sz="2600" b="0">
-                <a:solidFill>
-                  <a:srgbClr val="53676D"/>
-                </a:solidFill>
-                <a:latin typeface="Arial"/>
-                <a:ea typeface="Arial"/>
-                <a:cs typeface="Arial"/>
+              <a:rPr sz="2800" b="0">
+                <a:solidFill>
+                  <a:srgbClr val="53676D"/>
+                </a:solidFill>
+                <a:latin typeface="Arial" charset="0"/>
+                <a:ea typeface="Arial" charset="0"/>
+                <a:cs typeface="Arial" charset="0"/>
               </a:rPr>
               <a:t>eceipted </a:t>
             </a:r>
-            <a:endParaRPr sz="2600" b="0">
+            <a:endParaRPr lang="ko-KR" altLang="en-US" sz="2800" b="0">
               <a:solidFill>
                 <a:srgbClr val="53676D"/>
               </a:solidFill>
-              <a:latin typeface="Arial"/>
-              <a:ea typeface="Arial"/>
-              <a:cs typeface="Arial"/>
+              <a:latin typeface="Arial" charset="0"/>
+              <a:ea typeface="Arial" charset="0"/>
+              <a:cs typeface="Arial" charset="0"/>
             </a:endParaRPr>
           </a:p>
           <a:p>
-            <a:pPr algn="l">
+            <a:pPr marL="0" indent="0" algn="l">
+              <a:buFontTx/>
               <a:buNone/>
               <a:defRPr sz="1750" b="0">
                 <a:solidFill>
                   <a:srgbClr val="53676D"/>
                 </a:solidFill>
-                <a:latin typeface="Arial"/>
-                <a:ea typeface="Arial"/>
-                <a:cs typeface="Arial"/>
+                <a:latin typeface="Arial" charset="0"/>
+                <a:ea typeface="Arial" charset="0"/>
+                <a:cs typeface="Arial" charset="0"/>
               </a:defRPr>
             </a:pPr>
-            <a:endParaRPr sz="2600" b="0">
+            <a:endParaRPr lang="ko-KR" altLang="en-US" sz="2800" b="0">
               <a:solidFill>
                 <a:srgbClr val="53676D"/>
               </a:solidFill>
-              <a:latin typeface="Arial"/>
-              <a:ea typeface="Arial"/>
-              <a:cs typeface="Arial"/>
+              <a:latin typeface="Arial" charset="0"/>
+              <a:ea typeface="Arial" charset="0"/>
+              <a:cs typeface="Arial" charset="0"/>
             </a:endParaRPr>
           </a:p>
           <a:p>
-            <a:pPr algn="l">
+            <a:pPr marL="0" indent="0" algn="l">
+              <a:buFontTx/>
               <a:buNone/>
               <a:defRPr sz="1750" b="0">
                 <a:solidFill>
                   <a:srgbClr val="53676D"/>
                 </a:solidFill>
-                <a:latin typeface="Arial"/>
-                <a:ea typeface="Arial"/>
-                <a:cs typeface="Arial"/>
+                <a:latin typeface="Arial" charset="0"/>
+                <a:ea typeface="Arial" charset="0"/>
+                <a:cs typeface="Arial" charset="0"/>
               </a:defRPr>
             </a:pPr>
             <a:r>
@@ -7257,30 +7329,30 @@
                 <a:solidFill>
                   <a:srgbClr val="53676D"/>
                 </a:solidFill>
-                <a:latin typeface="Arial"/>
-                <a:ea typeface="Arial"/>
-                <a:cs typeface="Arial"/>
+                <a:latin typeface="Arial" charset="0"/>
+                <a:ea typeface="Arial" charset="0"/>
+                <a:cs typeface="Arial" charset="0"/>
               </a:rPr>
               <a:t>E</a:t>
             </a:r>
             <a:r>
-              <a:rPr sz="2600" b="0">
-                <a:solidFill>
-                  <a:srgbClr val="53676D"/>
-                </a:solidFill>
-                <a:latin typeface="Arial"/>
-                <a:ea typeface="Arial"/>
-                <a:cs typeface="Arial"/>
+              <a:rPr sz="2800" b="0">
+                <a:solidFill>
+                  <a:srgbClr val="53676D"/>
+                </a:solidFill>
+                <a:latin typeface="Arial" charset="0"/>
+                <a:ea typeface="Arial" charset="0"/>
+                <a:cs typeface="Arial" charset="0"/>
               </a:rPr>
               <a:t>quity</a:t>
             </a:r>
-            <a:endParaRPr sz="2600" b="0">
+            <a:endParaRPr lang="ko-KR" altLang="en-US" sz="2800" b="0">
               <a:solidFill>
                 <a:srgbClr val="53676D"/>
               </a:solidFill>
-              <a:latin typeface="Arial"/>
-              <a:ea typeface="Arial"/>
-              <a:cs typeface="Arial"/>
+              <a:latin typeface="Arial" charset="0"/>
+              <a:ea typeface="Arial" charset="0"/>
+              <a:cs typeface="Arial" charset="0"/>
             </a:endParaRPr>
           </a:p>
         </p:txBody>
@@ -7291,13 +7363,20 @@
     <a:masterClrMapping/>
   </p:clrMapOvr>
   <mc:AlternateContent xmlns:mc="http://schemas.openxmlformats.org/markup-compatibility/2006">
-    <mc:Choice xmlns:p159="http://schemas.microsoft.com/office/powerpoint/2015/09/main" xmlns:p14="http://schemas.microsoft.com/office/powerpoint/2010/main" Requires="p159">
-      <p:transition p14:dur="2000" advClick="1"/>
+    <mc:Choice xmlns:p14="http://schemas.microsoft.com/office/powerpoint/2010/main" Requires="p14">
+      <p:transition spd="slow" p14:dur="2000"/>
     </mc:Choice>
     <mc:Fallback>
-      <p:transition advClick="1"/>
+      <p:transition spd="slow"/>
     </mc:Fallback>
   </mc:AlternateContent>
+  <p:timing>
+    <p:tnLst>
+      <p:par>
+        <p:cTn id="1" dur="indefinite" restart="never" nodeType="tmRoot"/>
+      </p:par>
+    </p:tnLst>
+  </p:timing>
 </p:sld>
 </file>
 

</xml_diff>

<commit_message>
Add Pitch summary slide 'Leading Payment Engine to Capital Market' across web, PDF and PPTX decks
</commit_message>
<xml_diff>
--- a/docs/publish/pitch-dshare/D-SHARE-Prime-Edition-15-Slides.pptx
+++ b/docs/publish/pitch-dshare/D-SHARE-Prime-Edition-15-Slides.pptx
@@ -23,6 +23,7 @@
     <p:sldId id="268" r:id="rId35"/>
     <p:sldId id="269" r:id="rId37"/>
     <p:sldId id="270" r:id="rId39"/>
+    <p:sldId id="271" r:id="rId22"/>
   </p:sldIdLst>
   <p:sldSz cx="12192000" cy="6858000"/>
   <p:notesSz cx="6858000" cy="9144000"/>
@@ -20188,6 +20189,99 @@
 </p:sld>
 </file>
 
+<file path=ppt/slides/slide16.xml><?xml version="1.0" encoding="utf-8"?>
+<p:sld xmlns:a="http://schemas.openxmlformats.org/drawingml/2006/main" xmlns:p="http://schemas.openxmlformats.org/presentationml/2006/main" xmlns:r="http://schemas.openxmlformats.org/officeDocument/2006/relationships">
+  <p:cSld>
+    <p:bg>
+      <p:bgPr>
+        <a:solidFill>
+          <a:srgbClr val="F7F4EC"/>
+        </a:solidFill>
+        <a:effectLst/>
+      </p:bgPr>
+    </p:bg>
+    <p:spTree>
+      <p:nvGrpSpPr>
+        <p:cNvPr id="1" name=""/>
+        <p:cNvGrpSpPr/>
+        <p:nvPr/>
+      </p:nvGrpSpPr>
+      <p:grpSpPr/>
+      <p:pic>
+        <p:nvPicPr>
+          <p:cNvPr id="2" name="Picture 1" descr="slide16_prime_4k.png"/>
+          <p:cNvPicPr>
+            <a:picLocks noChangeAspect="1"/>
+          </p:cNvPicPr>
+          <p:nvPr/>
+        </p:nvPicPr>
+        <p:blipFill>
+          <a:blip r:embed="rId6"/>
+          <a:stretch>
+            <a:fillRect/>
+          </a:stretch>
+        </p:blipFill>
+        <p:spPr>
+          <a:xfrm>
+            <a:off x="0" y="0"/>
+            <a:ext cx="12192000" cy="6858000"/>
+          </a:xfrm>
+          <a:prstGeom prst="rect">
+            <a:avLst/>
+          </a:prstGeom>
+        </p:spPr>
+      </p:pic>
+      <p:sp>
+        <p:nvSpPr>
+          <p:cNvPr id="3" name="Rectangle 2">
+            <a:hlinkClick r:id="rId7"/>
+          </p:cNvPr>
+          <p:cNvSpPr/>
+          <p:nvPr/>
+        </p:nvSpPr>
+        <p:spPr>
+          <a:xfrm>
+            <a:off x="8521992" y="4744473"/>
+            <a:ext cx="1606992" cy="262758"/>
+          </a:xfrm>
+          <a:prstGeom prst="rect">
+            <a:avLst/>
+          </a:prstGeom>
+          <a:noFill/>
+          <a:ln>
+            <a:noFill/>
+          </a:ln>
+        </p:spPr>
+        <p:style>
+          <a:lnRef idx="1">
+            <a:schemeClr val="accent1"/>
+          </a:lnRef>
+          <a:fillRef idx="3">
+            <a:schemeClr val="accent1"/>
+          </a:fillRef>
+          <a:effectRef idx="2">
+            <a:schemeClr val="accent1"/>
+          </a:effectRef>
+          <a:fontRef idx="minor">
+            <a:schemeClr val="lt1"/>
+          </a:fontRef>
+        </p:style>
+        <p:txBody>
+          <a:bodyPr rtlCol="0" anchor="ctr"/>
+          <a:lstStyle/>
+          <a:p>
+            <a:pPr algn="ctr"/>
+          </a:p>
+        </p:txBody>
+      </p:sp>
+    </p:spTree>
+  </p:cSld>
+  <p:clrMapOvr>
+    <a:masterClrMapping/>
+  </p:clrMapOvr>
+</p:sld>
+</file>
+
 <file path=ppt/slides/slide2.xml><?xml version="1.0" encoding="utf-8"?>
 <p:sld xmlns:a="http://schemas.openxmlformats.org/drawingml/2006/main" xmlns:r="http://schemas.openxmlformats.org/officeDocument/2006/relationships" xmlns:p="http://schemas.openxmlformats.org/presentationml/2006/main" xmlns:m="http://schemas.openxmlformats.org/officeDocument/2006/math" xmlns:w="http://schemas.openxmlformats.org/wordprocessingml/2006/main" xmlns:mc="http://schemas.openxmlformats.org/markup-compatibility/2006" showMasterPhAnim="0" showMasterSp="1" show="1">
   <p:cSld name="">

</xml_diff>